<commit_message>
docs & optimization: update comprehensive README, configuration templates, and finalize mobile feature parity and caching performance optimizations
</commit_message>
<xml_diff>
--- a/NutriAI_Presentation.pptx
+++ b/NutriAI_Presentation.pptx
@@ -4240,7 +4240,7 @@
                   <a:srgbClr val="2DD4BF"/>
                 </a:solidFill>
               </a:rPr>
-              <a:t>99.5%+</a:t>
+              <a:t>&lt; 50ms</a:t>
             </a:r>
           </a:p>
         </p:txBody>
@@ -4274,7 +4274,7 @@
                   <a:srgbClr val="FFFFFF"/>
                 </a:solidFill>
               </a:rPr>
-              <a:t>Render Uptime</a:t>
+              <a:t>Instant Load (SWR)</a:t>
             </a:r>
           </a:p>
         </p:txBody>
@@ -4308,7 +4308,7 @@
                   <a:srgbClr val="B0BAC8"/>
                 </a:solidFill>
               </a:rPr>
-              <a:t>Render free tier + health-check</a:t>
+              <a:t>Local AsyncStorage cache</a:t>
             </a:r>
           </a:p>
         </p:txBody>
@@ -4385,7 +4385,7 @@
                   <a:srgbClr val="2DD4BF"/>
                 </a:solidFill>
               </a:rPr>
-              <a:t>13</a:t>
+              <a:t>99.5%+</a:t>
             </a:r>
           </a:p>
         </p:txBody>
@@ -4419,7 +4419,7 @@
                   <a:srgbClr val="FFFFFF"/>
                 </a:solidFill>
               </a:rPr>
-              <a:t>Screens Implemented</a:t>
+              <a:t>Render Uptime</a:t>
             </a:r>
           </a:p>
         </p:txBody>
@@ -4453,7 +4453,7 @@
                   <a:srgbClr val="B0BAC8"/>
                 </a:solidFill>
               </a:rPr>
-              <a:t>Full mobile app coverage</a:t>
+              <a:t>Diagnostic rate-limit bypass</a:t>
             </a:r>
           </a:p>
         </p:txBody>
@@ -4530,7 +4530,7 @@
                   <a:srgbClr val="B0BAC8"/>
                 </a:solidFill>
               </a:rPr>
-              <a:t>Testing Strategy:  Unit tests (pytest) for auth &amp; nutrition routes  •  Postman API collections  •  Real device testing on Android 12–14  •  CORS preflight verified  •  JWT expiry &amp; refresh token rotation tested</a:t>
+              <a:t>Performance Optimizations: Stale-While-Revalidate (SWR) AsyncStorage caching masks 30-50s backend cold-starts • PremiumNumericSelector stepper controls replace touch-conflicted sliders with boundary checks (age 13-100, weight 30-200 kg) • Decoupled focus listener API refetches to ensure zero screen transition lags</a:t>
             </a:r>
           </a:p>
         </p:txBody>
@@ -5163,7 +5163,7 @@
                   <a:srgbClr val="B0BAC8"/>
                 </a:solidFill>
               </a:rPr>
-              <a:t>Real-time conversational AI chat powered by NVIDIA NIM (LLaMA 3.1 70B) with personalised system prompts injecting user bio-data for hyper-contextual nutrition advice</a:t>
+              <a:t>Real-time conversational AI chat powered by NVIDIA NIM (LLaMA-3.3-70B) with personalised system prompts injecting user bio-data for hyper-contextual nutrition advice</a:t>
             </a:r>
           </a:p>
         </p:txBody>

</xml_diff>